<commit_message>
more presentation and design
</commit_message>
<xml_diff>
--- a/Prezentaciq.pptx
+++ b/Prezentaciq.pptx
@@ -5,11 +5,12 @@
     <p:sldMasterId id="2147483648" r:id="rId1"/>
   </p:sldMasterIdLst>
   <p:notesMasterIdLst>
-    <p:notesMasterId r:id="rId6"/>
+    <p:notesMasterId r:id="rId7"/>
   </p:notesMasterIdLst>
   <p:sldIdLst>
     <p:sldId id="256" r:id="rId4"/>
     <p:sldId id="257" r:id="rId5"/>
+    <p:sldId id="258" r:id="rId6"/>
   </p:sldIdLst>
   <p:sldSz cx="12192000" cy="6858000"/>
   <p:notesSz cx="6858000" cy="9144000"/>
@@ -135,7 +136,7 @@
       </p:grpSpPr>
       <p:sp>
         <p:nvSpPr>
-          <p:cNvPr id="1995646604" name="Header Placeholder 1"/>
+          <p:cNvPr id="111184141" name="Header Placeholder 1"/>
           <p:cNvSpPr>
             <a:spLocks noGrp="1"/>
           </p:cNvSpPr>
@@ -169,7 +170,7 @@
       </p:sp>
       <p:sp>
         <p:nvSpPr>
-          <p:cNvPr id="280467923" name="Date Placeholder 2"/>
+          <p:cNvPr id="424996992" name="Date Placeholder 2"/>
           <p:cNvSpPr>
             <a:spLocks noGrp="1"/>
           </p:cNvSpPr>
@@ -207,7 +208,7 @@
       </p:sp>
       <p:sp>
         <p:nvSpPr>
-          <p:cNvPr id="1890491167" name="Slide Image Placeholder 3"/>
+          <p:cNvPr id="1136400177" name="Slide Image Placeholder 3"/>
           <p:cNvSpPr>
             <a:spLocks noChangeAspect="1" noGrp="1" noRot="1"/>
           </p:cNvSpPr>
@@ -243,7 +244,7 @@
       </p:sp>
       <p:sp>
         <p:nvSpPr>
-          <p:cNvPr id="1313454087" name="Notes Placeholder 4"/>
+          <p:cNvPr id="256467042" name="Notes Placeholder 4"/>
           <p:cNvSpPr>
             <a:spLocks noGrp="1"/>
           </p:cNvSpPr>
@@ -317,7 +318,7 @@
       </p:sp>
       <p:sp>
         <p:nvSpPr>
-          <p:cNvPr id="502962620" name="Footer Placeholder 5"/>
+          <p:cNvPr id="1659420694" name="Footer Placeholder 5"/>
           <p:cNvSpPr>
             <a:spLocks noGrp="1"/>
           </p:cNvSpPr>
@@ -351,7 +352,7 @@
       </p:sp>
       <p:sp>
         <p:nvSpPr>
-          <p:cNvPr id="396950091" name="Slide Number Placeholder 6"/>
+          <p:cNvPr id="2073144657" name="Slide Number Placeholder 6"/>
           <p:cNvSpPr>
             <a:spLocks noGrp="1"/>
           </p:cNvSpPr>
@@ -504,7 +505,7 @@
       </p:grpSpPr>
       <p:sp>
         <p:nvSpPr>
-          <p:cNvPr id="2123346579" name="Slide Image Placeholder 1"/>
+          <p:cNvPr id="1205468750" name="Slide Image Placeholder 1"/>
           <p:cNvSpPr>
             <a:spLocks noChangeAspect="1" noGrp="1" noRot="1"/>
           </p:cNvSpPr>
@@ -521,7 +522,7 @@
       </p:sp>
       <p:sp>
         <p:nvSpPr>
-          <p:cNvPr id="420824283" name="Notes Placeholder 2"/>
+          <p:cNvPr id="1876952868" name="Notes Placeholder 2"/>
           <p:cNvSpPr>
             <a:spLocks noGrp="1"/>
           </p:cNvSpPr>
@@ -546,7 +547,7 @@
       </p:sp>
       <p:sp>
         <p:nvSpPr>
-          <p:cNvPr id="1575430289" name="Slide Number Placeholder 3"/>
+          <p:cNvPr id="1718582986" name="Slide Number Placeholder 3"/>
           <p:cNvSpPr>
             <a:spLocks noGrp="1"/>
           </p:cNvSpPr>
@@ -663,6 +664,91 @@
 </p:notes>
 </file>
 
+<file path=ppt/notesSlides/notesSlide3.xml><?xml version="1.0" encoding="utf-8"?>
+<p:notes xmlns:a="http://schemas.openxmlformats.org/drawingml/2006/main" xmlns:r="http://schemas.openxmlformats.org/officeDocument/2006/relationships" xmlns:p="http://schemas.openxmlformats.org/presentationml/2006/main" xmlns:m="http://schemas.openxmlformats.org/officeDocument/2006/math" xmlns:w="http://schemas.openxmlformats.org/wordprocessingml/2006/main">
+  <p:cSld name="">
+    <p:spTree>
+      <p:nvGrpSpPr>
+        <p:cNvPr id="1" name=""/>
+        <p:cNvGrpSpPr/>
+        <p:nvPr/>
+      </p:nvGrpSpPr>
+      <p:grpSpPr bwMode="auto">
+        <a:xfrm>
+          <a:off x="0" y="0"/>
+          <a:ext cx="0" cy="0"/>
+          <a:chOff x="0" y="0"/>
+          <a:chExt cx="0" cy="0"/>
+        </a:xfrm>
+      </p:grpSpPr>
+      <p:sp>
+        <p:nvSpPr>
+          <p:cNvPr id="2" name="Slide Image Placeholder 1"/>
+          <p:cNvSpPr>
+            <a:spLocks noChangeAspect="1" noGrp="1" noRot="1"/>
+          </p:cNvSpPr>
+          <p:nvPr>
+            <p:ph type="sldImg"/>
+          </p:nvPr>
+        </p:nvSpPr>
+        <p:spPr bwMode="auto"/>
+      </p:sp>
+      <p:sp>
+        <p:nvSpPr>
+          <p:cNvPr id="3" name="Notes Placeholder 2"/>
+          <p:cNvSpPr>
+            <a:spLocks noGrp="1"/>
+          </p:cNvSpPr>
+          <p:nvPr>
+            <p:ph type="body" idx="1"/>
+          </p:nvPr>
+        </p:nvSpPr>
+        <p:spPr bwMode="auto"/>
+        <p:txBody>
+          <a:bodyPr/>
+          <a:lstStyle/>
+          <a:p>
+            <a:pPr>
+              <a:defRPr/>
+            </a:pPr>
+            <a:endParaRPr/>
+          </a:p>
+        </p:txBody>
+      </p:sp>
+      <p:sp>
+        <p:nvSpPr>
+          <p:cNvPr id="4" name="Slide Number Placeholder 3"/>
+          <p:cNvSpPr>
+            <a:spLocks noGrp="1"/>
+          </p:cNvSpPr>
+          <p:nvPr>
+            <p:ph type="sldNum" sz="quarter" idx="10"/>
+          </p:nvPr>
+        </p:nvSpPr>
+        <p:spPr bwMode="auto"/>
+        <p:txBody>
+          <a:bodyPr/>
+          <a:lstStyle/>
+          <a:p>
+            <a:pPr>
+              <a:defRPr/>
+            </a:pPr>
+            <a:fld id="{B5D478D3-3B21-6817-CCC9-CB9B3836E056}" type="slidenum">
+              <a:rPr/>
+              <a:t/>
+            </a:fld>
+            <a:endParaRPr/>
+          </a:p>
+        </p:txBody>
+      </p:sp>
+    </p:spTree>
+  </p:cSld>
+  <p:clrMapOvr>
+    <a:masterClrMapping/>
+  </p:clrMapOvr>
+</p:notes>
+</file>
+
 <file path=ppt/slideLayouts/slideLayout1.xml><?xml version="1.0" encoding="utf-8"?>
 <p:sldLayout xmlns:a="http://schemas.openxmlformats.org/drawingml/2006/main" xmlns:r="http://schemas.openxmlformats.org/officeDocument/2006/relationships" xmlns:p="http://schemas.openxmlformats.org/presentationml/2006/main" xmlns:m="http://schemas.openxmlformats.org/officeDocument/2006/math" xmlns:w="http://schemas.openxmlformats.org/wordprocessingml/2006/main" matchingName="" preserve="1" showMasterPhAnim="0" showMasterSp="1" type="title" userDrawn="1">
   <p:cSld name="Title Slide">
@@ -682,7 +768,7 @@
       </p:grpSpPr>
       <p:sp>
         <p:nvSpPr>
-          <p:cNvPr id="436315733" name="Title 1"/>
+          <p:cNvPr id="628506171" name="Title 1"/>
           <p:cNvSpPr>
             <a:spLocks noGrp="1"/>
           </p:cNvSpPr>
@@ -717,7 +803,7 @@
       </p:sp>
       <p:sp>
         <p:nvSpPr>
-          <p:cNvPr id="1587590720" name="Subtitle 2"/>
+          <p:cNvPr id="212714472" name="Subtitle 2"/>
           <p:cNvSpPr>
             <a:spLocks noGrp="1"/>
           </p:cNvSpPr>
@@ -785,7 +871,7 @@
       </p:sp>
       <p:sp>
         <p:nvSpPr>
-          <p:cNvPr id="636050654" name="Date Placeholder 3"/>
+          <p:cNvPr id="127986693" name="Date Placeholder 3"/>
           <p:cNvSpPr>
             <a:spLocks noGrp="1"/>
           </p:cNvSpPr>
@@ -811,7 +897,7 @@
       </p:sp>
       <p:sp>
         <p:nvSpPr>
-          <p:cNvPr id="447175345" name="Footer Placeholder 4"/>
+          <p:cNvPr id="1377797319" name="Footer Placeholder 4"/>
           <p:cNvSpPr>
             <a:spLocks noGrp="1"/>
           </p:cNvSpPr>
@@ -833,7 +919,7 @@
       </p:sp>
       <p:sp>
         <p:nvSpPr>
-          <p:cNvPr id="1741302856" name="Slide Number Placeholder 5"/>
+          <p:cNvPr id="958003220" name="Slide Number Placeholder 5"/>
           <p:cNvSpPr>
             <a:spLocks noGrp="1"/>
           </p:cNvSpPr>
@@ -884,7 +970,7 @@
       </p:grpSpPr>
       <p:sp>
         <p:nvSpPr>
-          <p:cNvPr id="233374895" name="Title 1"/>
+          <p:cNvPr id="1573528504" name="Title 1"/>
           <p:cNvSpPr>
             <a:spLocks noGrp="1"/>
           </p:cNvSpPr>
@@ -910,7 +996,7 @@
       </p:sp>
       <p:sp>
         <p:nvSpPr>
-          <p:cNvPr id="1033548447" name="Vertical Text Placeholder 2"/>
+          <p:cNvPr id="1324261107" name="Vertical Text Placeholder 2"/>
           <p:cNvSpPr>
             <a:spLocks noGrp="1"/>
           </p:cNvSpPr>
@@ -976,7 +1062,7 @@
       </p:sp>
       <p:sp>
         <p:nvSpPr>
-          <p:cNvPr id="1897897824" name="Date Placeholder 3"/>
+          <p:cNvPr id="1569640140" name="Date Placeholder 3"/>
           <p:cNvSpPr>
             <a:spLocks noGrp="1"/>
           </p:cNvSpPr>
@@ -1002,7 +1088,7 @@
       </p:sp>
       <p:sp>
         <p:nvSpPr>
-          <p:cNvPr id="886328047" name="Footer Placeholder 4"/>
+          <p:cNvPr id="1844939002" name="Footer Placeholder 4"/>
           <p:cNvSpPr>
             <a:spLocks noGrp="1"/>
           </p:cNvSpPr>
@@ -1024,7 +1110,7 @@
       </p:sp>
       <p:sp>
         <p:nvSpPr>
-          <p:cNvPr id="523976275" name="Slide Number Placeholder 5"/>
+          <p:cNvPr id="460967716" name="Slide Number Placeholder 5"/>
           <p:cNvSpPr>
             <a:spLocks noGrp="1"/>
           </p:cNvSpPr>
@@ -1075,7 +1161,7 @@
       </p:grpSpPr>
       <p:sp>
         <p:nvSpPr>
-          <p:cNvPr id="1805500099" name="Vertical Title 1"/>
+          <p:cNvPr id="1457980043" name="Vertical Title 1"/>
           <p:cNvSpPr>
             <a:spLocks noGrp="1"/>
           </p:cNvSpPr>
@@ -1106,7 +1192,7 @@
       </p:sp>
       <p:sp>
         <p:nvSpPr>
-          <p:cNvPr id="61372409" name="Vertical Text Placeholder 2"/>
+          <p:cNvPr id="702582287" name="Vertical Text Placeholder 2"/>
           <p:cNvSpPr>
             <a:spLocks noGrp="1"/>
           </p:cNvSpPr>
@@ -1177,7 +1263,7 @@
       </p:sp>
       <p:sp>
         <p:nvSpPr>
-          <p:cNvPr id="1250420063" name="Date Placeholder 3"/>
+          <p:cNvPr id="1702442265" name="Date Placeholder 3"/>
           <p:cNvSpPr>
             <a:spLocks noGrp="1"/>
           </p:cNvSpPr>
@@ -1203,7 +1289,7 @@
       </p:sp>
       <p:sp>
         <p:nvSpPr>
-          <p:cNvPr id="582713578" name="Footer Placeholder 4"/>
+          <p:cNvPr id="2111041258" name="Footer Placeholder 4"/>
           <p:cNvSpPr>
             <a:spLocks noGrp="1"/>
           </p:cNvSpPr>
@@ -1225,7 +1311,7 @@
       </p:sp>
       <p:sp>
         <p:nvSpPr>
-          <p:cNvPr id="1010505652" name="Slide Number Placeholder 5"/>
+          <p:cNvPr id="127491273" name="Slide Number Placeholder 5"/>
           <p:cNvSpPr>
             <a:spLocks noGrp="1"/>
           </p:cNvSpPr>
@@ -1276,7 +1362,7 @@
       </p:grpSpPr>
       <p:sp>
         <p:nvSpPr>
-          <p:cNvPr id="992611268" name="Title 1"/>
+          <p:cNvPr id="870144705" name="Title 1"/>
           <p:cNvSpPr>
             <a:spLocks noGrp="1"/>
           </p:cNvSpPr>
@@ -1302,7 +1388,7 @@
       </p:sp>
       <p:sp>
         <p:nvSpPr>
-          <p:cNvPr id="1791502272" name="Content Placeholder 2"/>
+          <p:cNvPr id="2110699924" name="Content Placeholder 2"/>
           <p:cNvSpPr>
             <a:spLocks noGrp="1"/>
           </p:cNvSpPr>
@@ -1368,7 +1454,7 @@
       </p:sp>
       <p:sp>
         <p:nvSpPr>
-          <p:cNvPr id="1414948757" name="Date Placeholder 3"/>
+          <p:cNvPr id="966984649" name="Date Placeholder 3"/>
           <p:cNvSpPr>
             <a:spLocks noGrp="1"/>
           </p:cNvSpPr>
@@ -1394,7 +1480,7 @@
       </p:sp>
       <p:sp>
         <p:nvSpPr>
-          <p:cNvPr id="1178914373" name="Footer Placeholder 4"/>
+          <p:cNvPr id="875649945" name="Footer Placeholder 4"/>
           <p:cNvSpPr>
             <a:spLocks noGrp="1"/>
           </p:cNvSpPr>
@@ -1416,7 +1502,7 @@
       </p:sp>
       <p:sp>
         <p:nvSpPr>
-          <p:cNvPr id="957756936" name="Slide Number Placeholder 5"/>
+          <p:cNvPr id="218157647" name="Slide Number Placeholder 5"/>
           <p:cNvSpPr>
             <a:spLocks noGrp="1"/>
           </p:cNvSpPr>
@@ -1467,7 +1553,7 @@
       </p:grpSpPr>
       <p:sp>
         <p:nvSpPr>
-          <p:cNvPr id="219132990" name="Title 1"/>
+          <p:cNvPr id="1110052621" name="Title 1"/>
           <p:cNvSpPr>
             <a:spLocks noGrp="1"/>
           </p:cNvSpPr>
@@ -1502,7 +1588,7 @@
       </p:sp>
       <p:sp>
         <p:nvSpPr>
-          <p:cNvPr id="1867562593" name="Text Placeholder 2"/>
+          <p:cNvPr id="1013344636" name="Text Placeholder 2"/>
           <p:cNvSpPr>
             <a:spLocks noGrp="1"/>
           </p:cNvSpPr>
@@ -1624,7 +1710,7 @@
       </p:sp>
       <p:sp>
         <p:nvSpPr>
-          <p:cNvPr id="158211813" name="Date Placeholder 3"/>
+          <p:cNvPr id="582769811" name="Date Placeholder 3"/>
           <p:cNvSpPr>
             <a:spLocks noGrp="1"/>
           </p:cNvSpPr>
@@ -1650,7 +1736,7 @@
       </p:sp>
       <p:sp>
         <p:nvSpPr>
-          <p:cNvPr id="2115399187" name="Footer Placeholder 4"/>
+          <p:cNvPr id="532896224" name="Footer Placeholder 4"/>
           <p:cNvSpPr>
             <a:spLocks noGrp="1"/>
           </p:cNvSpPr>
@@ -1672,7 +1758,7 @@
       </p:sp>
       <p:sp>
         <p:nvSpPr>
-          <p:cNvPr id="187443181" name="Slide Number Placeholder 5"/>
+          <p:cNvPr id="2041265165" name="Slide Number Placeholder 5"/>
           <p:cNvSpPr>
             <a:spLocks noGrp="1"/>
           </p:cNvSpPr>
@@ -1723,7 +1809,7 @@
       </p:grpSpPr>
       <p:sp>
         <p:nvSpPr>
-          <p:cNvPr id="837587263" name="Title 1"/>
+          <p:cNvPr id="137167977" name="Title 1"/>
           <p:cNvSpPr>
             <a:spLocks noGrp="1"/>
           </p:cNvSpPr>
@@ -1749,7 +1835,7 @@
       </p:sp>
       <p:sp>
         <p:nvSpPr>
-          <p:cNvPr id="865809573" name="Content Placeholder 2"/>
+          <p:cNvPr id="1116256965" name="Content Placeholder 2"/>
           <p:cNvSpPr>
             <a:spLocks noGrp="1"/>
           </p:cNvSpPr>
@@ -1820,7 +1906,7 @@
       </p:sp>
       <p:sp>
         <p:nvSpPr>
-          <p:cNvPr id="444456435" name="Content Placeholder 3"/>
+          <p:cNvPr id="1866357068" name="Content Placeholder 3"/>
           <p:cNvSpPr>
             <a:spLocks noGrp="1"/>
           </p:cNvSpPr>
@@ -1891,7 +1977,7 @@
       </p:sp>
       <p:sp>
         <p:nvSpPr>
-          <p:cNvPr id="1462775476" name="Date Placeholder 4"/>
+          <p:cNvPr id="1543134294" name="Date Placeholder 4"/>
           <p:cNvSpPr>
             <a:spLocks noGrp="1"/>
           </p:cNvSpPr>
@@ -1917,7 +2003,7 @@
       </p:sp>
       <p:sp>
         <p:nvSpPr>
-          <p:cNvPr id="607649446" name="Footer Placeholder 5"/>
+          <p:cNvPr id="300894202" name="Footer Placeholder 5"/>
           <p:cNvSpPr>
             <a:spLocks noGrp="1"/>
           </p:cNvSpPr>
@@ -1939,7 +2025,7 @@
       </p:sp>
       <p:sp>
         <p:nvSpPr>
-          <p:cNvPr id="969068439" name="Slide Number Placeholder 6"/>
+          <p:cNvPr id="1121175188" name="Slide Number Placeholder 6"/>
           <p:cNvSpPr>
             <a:spLocks noGrp="1"/>
           </p:cNvSpPr>
@@ -1990,7 +2076,7 @@
       </p:grpSpPr>
       <p:sp>
         <p:nvSpPr>
-          <p:cNvPr id="1291771008" name="Title 1"/>
+          <p:cNvPr id="1972472927" name="Title 1"/>
           <p:cNvSpPr>
             <a:spLocks noGrp="1"/>
           </p:cNvSpPr>
@@ -2021,7 +2107,7 @@
       </p:sp>
       <p:sp>
         <p:nvSpPr>
-          <p:cNvPr id="1000721442" name="Text Placeholder 2"/>
+          <p:cNvPr id="144571322" name="Text Placeholder 2"/>
           <p:cNvSpPr>
             <a:spLocks noGrp="1"/>
           </p:cNvSpPr>
@@ -2089,7 +2175,7 @@
       </p:sp>
       <p:sp>
         <p:nvSpPr>
-          <p:cNvPr id="628130432" name="Content Placeholder 3"/>
+          <p:cNvPr id="1640996834" name="Content Placeholder 3"/>
           <p:cNvSpPr>
             <a:spLocks noGrp="1"/>
           </p:cNvSpPr>
@@ -2160,7 +2246,7 @@
       </p:sp>
       <p:sp>
         <p:nvSpPr>
-          <p:cNvPr id="860198485" name="Text Placeholder 4"/>
+          <p:cNvPr id="737505540" name="Text Placeholder 4"/>
           <p:cNvSpPr>
             <a:spLocks noGrp="1"/>
           </p:cNvSpPr>
@@ -2228,7 +2314,7 @@
       </p:sp>
       <p:sp>
         <p:nvSpPr>
-          <p:cNvPr id="1744296720" name="Content Placeholder 5"/>
+          <p:cNvPr id="1662852458" name="Content Placeholder 5"/>
           <p:cNvSpPr>
             <a:spLocks noGrp="1"/>
           </p:cNvSpPr>
@@ -2299,7 +2385,7 @@
       </p:sp>
       <p:sp>
         <p:nvSpPr>
-          <p:cNvPr id="1070844574" name="Date Placeholder 6"/>
+          <p:cNvPr id="485902517" name="Date Placeholder 6"/>
           <p:cNvSpPr>
             <a:spLocks noGrp="1"/>
           </p:cNvSpPr>
@@ -2325,7 +2411,7 @@
       </p:sp>
       <p:sp>
         <p:nvSpPr>
-          <p:cNvPr id="1976104690" name="Footer Placeholder 7"/>
+          <p:cNvPr id="278946314" name="Footer Placeholder 7"/>
           <p:cNvSpPr>
             <a:spLocks noGrp="1"/>
           </p:cNvSpPr>
@@ -2347,7 +2433,7 @@
       </p:sp>
       <p:sp>
         <p:nvSpPr>
-          <p:cNvPr id="572489037" name="Slide Number Placeholder 8"/>
+          <p:cNvPr id="195110367" name="Slide Number Placeholder 8"/>
           <p:cNvSpPr>
             <a:spLocks noGrp="1"/>
           </p:cNvSpPr>
@@ -2398,7 +2484,7 @@
       </p:grpSpPr>
       <p:sp>
         <p:nvSpPr>
-          <p:cNvPr id="1259775084" name="Title 1"/>
+          <p:cNvPr id="748215825" name="Title 1"/>
           <p:cNvSpPr>
             <a:spLocks noGrp="1"/>
           </p:cNvSpPr>
@@ -2424,7 +2510,7 @@
       </p:sp>
       <p:sp>
         <p:nvSpPr>
-          <p:cNvPr id="948983888" name="Date Placeholder 2"/>
+          <p:cNvPr id="1926251785" name="Date Placeholder 2"/>
           <p:cNvSpPr>
             <a:spLocks noGrp="1"/>
           </p:cNvSpPr>
@@ -2450,7 +2536,7 @@
       </p:sp>
       <p:sp>
         <p:nvSpPr>
-          <p:cNvPr id="1801675128" name="Footer Placeholder 3"/>
+          <p:cNvPr id="1680484661" name="Footer Placeholder 3"/>
           <p:cNvSpPr>
             <a:spLocks noGrp="1"/>
           </p:cNvSpPr>
@@ -2472,7 +2558,7 @@
       </p:sp>
       <p:sp>
         <p:nvSpPr>
-          <p:cNvPr id="1728430009" name="Slide Number Placeholder 4"/>
+          <p:cNvPr id="584321220" name="Slide Number Placeholder 4"/>
           <p:cNvSpPr>
             <a:spLocks noGrp="1"/>
           </p:cNvSpPr>
@@ -2523,7 +2609,7 @@
       </p:grpSpPr>
       <p:sp>
         <p:nvSpPr>
-          <p:cNvPr id="122521579" name="Date Placeholder 1"/>
+          <p:cNvPr id="1045704255" name="Date Placeholder 1"/>
           <p:cNvSpPr>
             <a:spLocks noGrp="1"/>
           </p:cNvSpPr>
@@ -2549,7 +2635,7 @@
       </p:sp>
       <p:sp>
         <p:nvSpPr>
-          <p:cNvPr id="1077704198" name="Footer Placeholder 2"/>
+          <p:cNvPr id="209439955" name="Footer Placeholder 2"/>
           <p:cNvSpPr>
             <a:spLocks noGrp="1"/>
           </p:cNvSpPr>
@@ -2571,7 +2657,7 @@
       </p:sp>
       <p:sp>
         <p:nvSpPr>
-          <p:cNvPr id="1189555456" name="Slide Number Placeholder 3"/>
+          <p:cNvPr id="1428059767" name="Slide Number Placeholder 3"/>
           <p:cNvSpPr>
             <a:spLocks noGrp="1"/>
           </p:cNvSpPr>
@@ -2622,7 +2708,7 @@
       </p:grpSpPr>
       <p:sp>
         <p:nvSpPr>
-          <p:cNvPr id="1217313151" name="Title 1"/>
+          <p:cNvPr id="2106341006" name="Title 1"/>
           <p:cNvSpPr>
             <a:spLocks noGrp="1"/>
           </p:cNvSpPr>
@@ -2657,7 +2743,7 @@
       </p:sp>
       <p:sp>
         <p:nvSpPr>
-          <p:cNvPr id="285650806" name="Content Placeholder 2"/>
+          <p:cNvPr id="879218208" name="Content Placeholder 2"/>
           <p:cNvSpPr>
             <a:spLocks noGrp="1"/>
           </p:cNvSpPr>
@@ -2756,7 +2842,7 @@
       </p:sp>
       <p:sp>
         <p:nvSpPr>
-          <p:cNvPr id="1784357812" name="Text Placeholder 3"/>
+          <p:cNvPr id="761997951" name="Text Placeholder 3"/>
           <p:cNvSpPr>
             <a:spLocks noGrp="1"/>
           </p:cNvSpPr>
@@ -2824,7 +2910,7 @@
       </p:sp>
       <p:sp>
         <p:nvSpPr>
-          <p:cNvPr id="174198518" name="Date Placeholder 4"/>
+          <p:cNvPr id="1933403739" name="Date Placeholder 4"/>
           <p:cNvSpPr>
             <a:spLocks noGrp="1"/>
           </p:cNvSpPr>
@@ -2850,7 +2936,7 @@
       </p:sp>
       <p:sp>
         <p:nvSpPr>
-          <p:cNvPr id="1019347401" name="Footer Placeholder 5"/>
+          <p:cNvPr id="1086449871" name="Footer Placeholder 5"/>
           <p:cNvSpPr>
             <a:spLocks noGrp="1"/>
           </p:cNvSpPr>
@@ -2872,7 +2958,7 @@
       </p:sp>
       <p:sp>
         <p:nvSpPr>
-          <p:cNvPr id="764286525" name="Slide Number Placeholder 6"/>
+          <p:cNvPr id="1570432118" name="Slide Number Placeholder 6"/>
           <p:cNvSpPr>
             <a:spLocks noGrp="1"/>
           </p:cNvSpPr>
@@ -2923,7 +3009,7 @@
       </p:grpSpPr>
       <p:sp>
         <p:nvSpPr>
-          <p:cNvPr id="1766711584" name="Title 1"/>
+          <p:cNvPr id="214873002" name="Title 1"/>
           <p:cNvSpPr>
             <a:spLocks noGrp="1"/>
           </p:cNvSpPr>
@@ -2958,7 +3044,7 @@
       </p:sp>
       <p:sp>
         <p:nvSpPr>
-          <p:cNvPr id="225121448" name="Picture Placeholder 2"/>
+          <p:cNvPr id="1387180197" name="Picture Placeholder 2"/>
           <p:cNvSpPr>
             <a:spLocks noChangeAspect="1" noGrp="1"/>
           </p:cNvSpPr>
@@ -3026,7 +3112,7 @@
       </p:sp>
       <p:sp>
         <p:nvSpPr>
-          <p:cNvPr id="241838834" name="Text Placeholder 3"/>
+          <p:cNvPr id="1007549447" name="Text Placeholder 3"/>
           <p:cNvSpPr>
             <a:spLocks noGrp="1"/>
           </p:cNvSpPr>
@@ -3094,7 +3180,7 @@
       </p:sp>
       <p:sp>
         <p:nvSpPr>
-          <p:cNvPr id="834108255" name="Date Placeholder 4"/>
+          <p:cNvPr id="1791895889" name="Date Placeholder 4"/>
           <p:cNvSpPr>
             <a:spLocks noGrp="1"/>
           </p:cNvSpPr>
@@ -3120,7 +3206,7 @@
       </p:sp>
       <p:sp>
         <p:nvSpPr>
-          <p:cNvPr id="1050869291" name="Footer Placeholder 5"/>
+          <p:cNvPr id="1763542879" name="Footer Placeholder 5"/>
           <p:cNvSpPr>
             <a:spLocks noGrp="1"/>
           </p:cNvSpPr>
@@ -3142,7 +3228,7 @@
       </p:sp>
       <p:sp>
         <p:nvSpPr>
-          <p:cNvPr id="1539431622" name="Slide Number Placeholder 6"/>
+          <p:cNvPr id="1160929360" name="Slide Number Placeholder 6"/>
           <p:cNvSpPr>
             <a:spLocks noGrp="1"/>
           </p:cNvSpPr>
@@ -3201,7 +3287,7 @@
       </p:grpSpPr>
       <p:sp>
         <p:nvSpPr>
-          <p:cNvPr id="705912059" name="Title Placeholder 1"/>
+          <p:cNvPr id="718380730" name="Title Placeholder 1"/>
           <p:cNvSpPr>
             <a:spLocks noGrp="1"/>
           </p:cNvSpPr>
@@ -3237,7 +3323,7 @@
       </p:sp>
       <p:sp>
         <p:nvSpPr>
-          <p:cNvPr id="1979594582" name="Text Placeholder 2"/>
+          <p:cNvPr id="2078194988" name="Text Placeholder 2"/>
           <p:cNvSpPr>
             <a:spLocks noGrp="1"/>
           </p:cNvSpPr>
@@ -3313,7 +3399,7 @@
       </p:sp>
       <p:sp>
         <p:nvSpPr>
-          <p:cNvPr id="1857861994" name="Date Placeholder 3"/>
+          <p:cNvPr id="420560671" name="Date Placeholder 3"/>
           <p:cNvSpPr>
             <a:spLocks noGrp="1"/>
           </p:cNvSpPr>
@@ -3357,7 +3443,7 @@
       </p:sp>
       <p:sp>
         <p:nvSpPr>
-          <p:cNvPr id="478000238" name="Footer Placeholder 4"/>
+          <p:cNvPr id="1565922673" name="Footer Placeholder 4"/>
           <p:cNvSpPr>
             <a:spLocks noGrp="1"/>
           </p:cNvSpPr>
@@ -3397,7 +3483,7 @@
       </p:sp>
       <p:sp>
         <p:nvSpPr>
-          <p:cNvPr id="1172708282" name="Slide Number Placeholder 5"/>
+          <p:cNvPr id="1824967276" name="Slide Number Placeholder 5"/>
           <p:cNvSpPr>
             <a:spLocks noGrp="1"/>
           </p:cNvSpPr>
@@ -3757,7 +3843,7 @@
       </p:grpSpPr>
       <p:sp>
         <p:nvSpPr>
-          <p:cNvPr id="710601938" name="Title 1"/>
+          <p:cNvPr id="2101572661" name="Title 1"/>
           <p:cNvSpPr>
             <a:spLocks noGrp="1"/>
           </p:cNvSpPr>
@@ -3801,7 +3887,7 @@
       </p:sp>
       <p:sp>
         <p:nvSpPr>
-          <p:cNvPr id="1970887236" name="Subtitle 2"/>
+          <p:cNvPr id="1604452101" name="Subtitle 2"/>
           <p:cNvSpPr>
             <a:spLocks noGrp="1"/>
           </p:cNvSpPr>
@@ -3944,7 +4030,7 @@
         <p:spPr bwMode="auto">
           <a:xfrm rot="0" flipH="0" flipV="0">
             <a:off x="953892" y="1510392"/>
-            <a:ext cx="8810733" cy="2072999"/>
+            <a:ext cx="8829813" cy="2072999"/>
           </a:xfrm>
           <a:prstGeom prst="rect">
             <a:avLst/>
@@ -3982,6 +4068,36 @@
               </a:rPr>
               <a:t>, дизайн</a:t>
             </a:r>
+            <a:r>
+              <a:rPr lang="en-US" sz="2600">
+                <a:solidFill>
+                  <a:schemeClr val="bg1"/>
+                </a:solidFill>
+                <a:latin typeface="Ubuntu Sans"/>
+                <a:cs typeface="Ubuntu Sans"/>
+              </a:rPr>
+              <a:t> </a:t>
+            </a:r>
+            <a:r>
+              <a:rPr lang="bg-BG" sz="2600">
+                <a:solidFill>
+                  <a:schemeClr val="bg1"/>
+                </a:solidFill>
+                <a:latin typeface="Ubuntu Sans"/>
+                <a:cs typeface="Ubuntu Sans"/>
+              </a:rPr>
+              <a:t>и </a:t>
+            </a:r>
+            <a:r>
+              <a:rPr lang="en-US" sz="2600">
+                <a:solidFill>
+                  <a:schemeClr val="bg1"/>
+                </a:solidFill>
+                <a:latin typeface="Ubuntu Sans"/>
+                <a:cs typeface="Ubuntu Sans"/>
+              </a:rPr>
+              <a:t>GitHub</a:t>
+            </a:r>
             <a:endParaRPr sz="2600">
               <a:solidFill>
                 <a:schemeClr val="bg1"/>
@@ -4071,6 +4187,28 @@
               </a:rPr>
               <a:t>Александър Симеонов</a:t>
             </a:r>
+            <a:r>
+              <a:rPr lang="en-US" sz="2600">
+                <a:solidFill>
+                  <a:schemeClr val="bg1"/>
+                </a:solidFill>
+                <a:latin typeface="Ubuntu Sans"/>
+                <a:ea typeface="Ubuntu Sans"/>
+                <a:cs typeface="Ubuntu Sans"/>
+              </a:rPr>
+              <a:t> - </a:t>
+            </a:r>
+            <a:r>
+              <a:rPr lang="bg-BG" sz="2600">
+                <a:solidFill>
+                  <a:schemeClr val="bg1"/>
+                </a:solidFill>
+                <a:latin typeface="Ubuntu Sans"/>
+                <a:ea typeface="Ubuntu Sans"/>
+                <a:cs typeface="Ubuntu Sans"/>
+              </a:rPr>
+              <a:t>правене на сайт</a:t>
+            </a:r>
             <a:endParaRPr sz="2600">
               <a:solidFill>
                 <a:schemeClr val="bg1"/>
@@ -4096,6 +4234,17 @@
                 <a:cs typeface="Ubuntu Sans"/>
               </a:rPr>
               <a:t>Илиян Сахатчиев</a:t>
+            </a:r>
+            <a:r>
+              <a:rPr lang="en-US" sz="2600">
+                <a:solidFill>
+                  <a:schemeClr val="bg1"/>
+                </a:solidFill>
+                <a:latin typeface="Ubuntu Sans"/>
+                <a:ea typeface="Ubuntu Sans"/>
+                <a:cs typeface="Ubuntu Sans"/>
+              </a:rPr>
+              <a:t> - backend</a:t>
             </a:r>
             <a:endParaRPr>
               <a:solidFill>
@@ -4154,6 +4303,168 @@
               <a:t>Никола Кръстанов</a:t>
             </a:r>
             <a:endParaRPr b="0">
+              <a:solidFill>
+                <a:schemeClr val="bg1"/>
+              </a:solidFill>
+            </a:endParaRPr>
+          </a:p>
+        </p:txBody>
+      </p:sp>
+    </p:spTree>
+  </p:cSld>
+  <p:clrMapOvr>
+    <a:masterClrMapping/>
+  </p:clrMapOvr>
+  <mc:AlternateContent xmlns:mc="http://schemas.openxmlformats.org/markup-compatibility/2006">
+    <mc:Choice xmlns:p159="http://schemas.microsoft.com/office/powerpoint/2015/09/main" xmlns:p14="http://schemas.microsoft.com/office/powerpoint/2010/main" Requires="p159">
+      <p:transition p14:dur="500" advClick="1"/>
+    </mc:Choice>
+    <mc:Fallback>
+      <p:transition advClick="1"/>
+    </mc:Fallback>
+  </mc:AlternateContent>
+</p:sld>
+</file>
+
+<file path=ppt/slides/slide3.xml><?xml version="1.0" encoding="utf-8"?>
+<p:sld xmlns:a="http://schemas.openxmlformats.org/drawingml/2006/main" xmlns:r="http://schemas.openxmlformats.org/officeDocument/2006/relationships" xmlns:p="http://schemas.openxmlformats.org/presentationml/2006/main" xmlns:m="http://schemas.openxmlformats.org/officeDocument/2006/math" xmlns:w="http://schemas.openxmlformats.org/wordprocessingml/2006/main" xmlns:mc="http://schemas.openxmlformats.org/markup-compatibility/2006" showMasterPhAnim="0" showMasterSp="1" show="1">
+  <p:cSld name="">
+    <p:spTree>
+      <p:nvGrpSpPr>
+        <p:cNvPr id="1" name=""/>
+        <p:cNvGrpSpPr/>
+        <p:nvPr/>
+      </p:nvGrpSpPr>
+      <p:grpSpPr bwMode="auto">
+        <a:xfrm>
+          <a:off x="0" y="0"/>
+          <a:ext cx="0" cy="0"/>
+          <a:chOff x="0" y="0"/>
+          <a:chExt cx="0" cy="0"/>
+        </a:xfrm>
+      </p:grpSpPr>
+      <p:sp>
+        <p:nvSpPr>
+          <p:cNvPr id="745327546" name="Title 1"/>
+          <p:cNvSpPr>
+            <a:spLocks noGrp="1"/>
+          </p:cNvSpPr>
+          <p:nvPr>
+            <p:ph type="ctrTitle"/>
+          </p:nvPr>
+        </p:nvSpPr>
+        <p:spPr bwMode="auto">
+          <a:xfrm flipH="0" flipV="0">
+            <a:off x="721176" y="251504"/>
+            <a:ext cx="6886608" cy="1381351"/>
+          </a:xfrm>
+        </p:spPr>
+        <p:txBody>
+          <a:bodyPr/>
+          <a:lstStyle/>
+          <a:p>
+            <a:pPr>
+              <a:defRPr/>
+            </a:pPr>
+            <a:r>
+              <a:rPr lang="bg-BG" b="1">
+                <a:solidFill>
+                  <a:schemeClr val="bg1"/>
+                </a:solidFill>
+                <a:latin typeface="Ubuntu Sans"/>
+                <a:cs typeface="Ubuntu Sans"/>
+              </a:rPr>
+              <a:t>Идеята – от къде и защо?</a:t>
+            </a:r>
+            <a:endParaRPr b="1">
+              <a:solidFill>
+                <a:schemeClr val="bg1"/>
+              </a:solidFill>
+              <a:latin typeface="Ubuntu Sans"/>
+              <a:cs typeface="Ubuntu Sans"/>
+            </a:endParaRPr>
+          </a:p>
+        </p:txBody>
+      </p:sp>
+      <p:sp>
+        <p:nvSpPr>
+          <p:cNvPr id="440238925" name=""/>
+          <p:cNvSpPr txBox="1"/>
+          <p:nvPr/>
+        </p:nvSpPr>
+        <p:spPr bwMode="auto">
+          <a:xfrm rot="0" flipH="0" flipV="0">
+            <a:off x="559285" y="1442356"/>
+            <a:ext cx="8367171" cy="914760"/>
+          </a:xfrm>
+          <a:prstGeom prst="rect">
+            <a:avLst/>
+          </a:prstGeom>
+          <a:noFill/>
+        </p:spPr>
+        <p:txBody>
+          <a:bodyPr vertOverflow="overflow" horzOverflow="overflow" vert="horz" wrap="square" lIns="91440" tIns="45720" rIns="91440" bIns="45720" numCol="1" spcCol="0" rtlCol="0" fromWordArt="0" anchor="t" anchorCtr="0" forceAA="0" upright="0" compatLnSpc="0">
+            <a:spAutoFit/>
+          </a:bodyPr>
+          <a:p>
+            <a:pPr marL="283879" indent="-283879">
+              <a:buFont typeface="Arial"/>
+              <a:buChar char="•"/>
+              <a:defRPr/>
+            </a:pPr>
+            <a:r>
+              <a:rPr lang="bg-BG">
+                <a:solidFill>
+                  <a:schemeClr val="bg1"/>
+                </a:solidFill>
+              </a:rPr>
+              <a:t>Проблемите на инд</a:t>
+            </a:r>
+            <a:r>
+              <a:rPr lang="bg-BG">
+                <a:solidFill>
+                  <a:schemeClr val="bg1"/>
+                </a:solidFill>
+              </a:rPr>
+              <a:t>ивиди с деменция</a:t>
+            </a:r>
+            <a:endParaRPr lang="bg-BG">
+              <a:solidFill>
+                <a:schemeClr val="bg1"/>
+              </a:solidFill>
+            </a:endParaRPr>
+          </a:p>
+          <a:p>
+            <a:pPr>
+              <a:defRPr/>
+            </a:pPr>
+            <a:r>
+              <a:rPr lang="bg-BG">
+                <a:solidFill>
+                  <a:schemeClr val="bg1"/>
+                </a:solidFill>
+              </a:rPr>
+              <a:t>	- Силни шумове и светлини</a:t>
+            </a:r>
+            <a:endParaRPr lang="bg-BG">
+              <a:solidFill>
+                <a:schemeClr val="bg1"/>
+              </a:solidFill>
+            </a:endParaRPr>
+          </a:p>
+          <a:p>
+            <a:pPr>
+              <a:defRPr/>
+            </a:pPr>
+            <a:r>
+              <a:rPr lang="bg-BG">
+                <a:solidFill>
+                  <a:schemeClr val="bg1"/>
+                </a:solidFill>
+              </a:rPr>
+              <a:t>	- Забравяне</a:t>
+            </a:r>
+            <a:endParaRPr>
               <a:solidFill>
                 <a:schemeClr val="bg1"/>
               </a:solidFill>

</xml_diff>

<commit_message>
final final final presentation
</commit_message>
<xml_diff>
--- a/Prezentaciq.pptx
+++ b/Prezentaciq.pptx
@@ -147,7 +147,7 @@
       </p:grpSpPr>
       <p:sp>
         <p:nvSpPr>
-          <p:cNvPr id="58436473" name="Header Placeholder 1"/>
+          <p:cNvPr id="2050368456" name="Header Placeholder 1"/>
           <p:cNvSpPr>
             <a:spLocks noGrp="1"/>
           </p:cNvSpPr>
@@ -181,7 +181,7 @@
       </p:sp>
       <p:sp>
         <p:nvSpPr>
-          <p:cNvPr id="533549276" name="Date Placeholder 2"/>
+          <p:cNvPr id="192034362" name="Date Placeholder 2"/>
           <p:cNvSpPr>
             <a:spLocks noGrp="1"/>
           </p:cNvSpPr>
@@ -219,7 +219,7 @@
       </p:sp>
       <p:sp>
         <p:nvSpPr>
-          <p:cNvPr id="718225031" name="Slide Image Placeholder 3"/>
+          <p:cNvPr id="361398548" name="Slide Image Placeholder 3"/>
           <p:cNvSpPr>
             <a:spLocks noChangeAspect="1" noGrp="1" noRot="1"/>
           </p:cNvSpPr>
@@ -255,7 +255,7 @@
       </p:sp>
       <p:sp>
         <p:nvSpPr>
-          <p:cNvPr id="286838563" name="Notes Placeholder 4"/>
+          <p:cNvPr id="1910018261" name="Notes Placeholder 4"/>
           <p:cNvSpPr>
             <a:spLocks noGrp="1"/>
           </p:cNvSpPr>
@@ -329,7 +329,7 @@
       </p:sp>
       <p:sp>
         <p:nvSpPr>
-          <p:cNvPr id="531845967" name="Footer Placeholder 5"/>
+          <p:cNvPr id="1208110132" name="Footer Placeholder 5"/>
           <p:cNvSpPr>
             <a:spLocks noGrp="1"/>
           </p:cNvSpPr>
@@ -363,7 +363,7 @@
       </p:sp>
       <p:sp>
         <p:nvSpPr>
-          <p:cNvPr id="1746309567" name="Slide Number Placeholder 6"/>
+          <p:cNvPr id="943943494" name="Slide Number Placeholder 6"/>
           <p:cNvSpPr>
             <a:spLocks noGrp="1"/>
           </p:cNvSpPr>
@@ -516,7 +516,7 @@
       </p:grpSpPr>
       <p:sp>
         <p:nvSpPr>
-          <p:cNvPr id="1306486001" name="Slide Image Placeholder 1"/>
+          <p:cNvPr id="1565249380" name="Slide Image Placeholder 1"/>
           <p:cNvSpPr>
             <a:spLocks noChangeAspect="1" noGrp="1" noRot="1"/>
           </p:cNvSpPr>
@@ -533,7 +533,7 @@
       </p:sp>
       <p:sp>
         <p:nvSpPr>
-          <p:cNvPr id="334811234" name="Notes Placeholder 2"/>
+          <p:cNvPr id="898492015" name="Notes Placeholder 2"/>
           <p:cNvSpPr>
             <a:spLocks noGrp="1"/>
           </p:cNvSpPr>
@@ -558,7 +558,7 @@
       </p:sp>
       <p:sp>
         <p:nvSpPr>
-          <p:cNvPr id="114077903" name="Slide Number Placeholder 3"/>
+          <p:cNvPr id="1436740331" name="Slide Number Placeholder 3"/>
           <p:cNvSpPr>
             <a:spLocks noGrp="1"/>
           </p:cNvSpPr>
@@ -609,7 +609,7 @@
       </p:grpSpPr>
       <p:sp>
         <p:nvSpPr>
-          <p:cNvPr id="280794990" name="Slide Image Placeholder 1"/>
+          <p:cNvPr id="1166718140" name="Slide Image Placeholder 1"/>
           <p:cNvSpPr>
             <a:spLocks noChangeAspect="1" noGrp="1" noRot="1"/>
           </p:cNvSpPr>
@@ -621,7 +621,7 @@
       </p:sp>
       <p:sp>
         <p:nvSpPr>
-          <p:cNvPr id="1370732853" name="Notes Placeholder 2"/>
+          <p:cNvPr id="2023877163" name="Notes Placeholder 2"/>
           <p:cNvSpPr>
             <a:spLocks noGrp="1"/>
           </p:cNvSpPr>
@@ -643,7 +643,7 @@
       </p:sp>
       <p:sp>
         <p:nvSpPr>
-          <p:cNvPr id="1046857221" name="Slide Number Placeholder 3"/>
+          <p:cNvPr id="703464308" name="Slide Number Placeholder 3"/>
           <p:cNvSpPr>
             <a:spLocks noGrp="1"/>
           </p:cNvSpPr>
@@ -694,7 +694,7 @@
       </p:grpSpPr>
       <p:sp>
         <p:nvSpPr>
-          <p:cNvPr id="513255465" name="Slide Image Placeholder 1"/>
+          <p:cNvPr id="410184070" name="Slide Image Placeholder 1"/>
           <p:cNvSpPr>
             <a:spLocks noChangeAspect="1" noGrp="1" noRot="1"/>
           </p:cNvSpPr>
@@ -706,7 +706,7 @@
       </p:sp>
       <p:sp>
         <p:nvSpPr>
-          <p:cNvPr id="201265743" name="Notes Placeholder 2"/>
+          <p:cNvPr id="226296137" name="Notes Placeholder 2"/>
           <p:cNvSpPr>
             <a:spLocks noGrp="1"/>
           </p:cNvSpPr>
@@ -728,7 +728,7 @@
       </p:sp>
       <p:sp>
         <p:nvSpPr>
-          <p:cNvPr id="706094252" name="Slide Number Placeholder 3"/>
+          <p:cNvPr id="1753647276" name="Slide Number Placeholder 3"/>
           <p:cNvSpPr>
             <a:spLocks noGrp="1"/>
           </p:cNvSpPr>
@@ -779,7 +779,7 @@
       </p:grpSpPr>
       <p:sp>
         <p:nvSpPr>
-          <p:cNvPr id="726774625" name="Slide Image Placeholder 1"/>
+          <p:cNvPr id="1363638184" name="Slide Image Placeholder 1"/>
           <p:cNvSpPr>
             <a:spLocks noChangeAspect="1" noGrp="1" noRot="1"/>
           </p:cNvSpPr>
@@ -791,7 +791,7 @@
       </p:sp>
       <p:sp>
         <p:nvSpPr>
-          <p:cNvPr id="1398756412" name="Notes Placeholder 2"/>
+          <p:cNvPr id="822912470" name="Notes Placeholder 2"/>
           <p:cNvSpPr>
             <a:spLocks noGrp="1"/>
           </p:cNvSpPr>
@@ -813,7 +813,7 @@
       </p:sp>
       <p:sp>
         <p:nvSpPr>
-          <p:cNvPr id="804975547" name="Slide Number Placeholder 3"/>
+          <p:cNvPr id="450607563" name="Slide Number Placeholder 3"/>
           <p:cNvSpPr>
             <a:spLocks noGrp="1"/>
           </p:cNvSpPr>
@@ -864,7 +864,7 @@
       </p:grpSpPr>
       <p:sp>
         <p:nvSpPr>
-          <p:cNvPr id="928911077" name="Slide Image Placeholder 1"/>
+          <p:cNvPr id="71504776" name="Slide Image Placeholder 1"/>
           <p:cNvSpPr>
             <a:spLocks noChangeAspect="1" noGrp="1" noRot="1"/>
           </p:cNvSpPr>
@@ -876,7 +876,7 @@
       </p:sp>
       <p:sp>
         <p:nvSpPr>
-          <p:cNvPr id="18493334" name="Notes Placeholder 2"/>
+          <p:cNvPr id="90241644" name="Notes Placeholder 2"/>
           <p:cNvSpPr>
             <a:spLocks noGrp="1"/>
           </p:cNvSpPr>
@@ -898,7 +898,7 @@
       </p:sp>
       <p:sp>
         <p:nvSpPr>
-          <p:cNvPr id="633197055" name="Slide Number Placeholder 3"/>
+          <p:cNvPr id="1866224512" name="Slide Number Placeholder 3"/>
           <p:cNvSpPr>
             <a:spLocks noGrp="1"/>
           </p:cNvSpPr>
@@ -949,7 +949,7 @@
       </p:grpSpPr>
       <p:sp>
         <p:nvSpPr>
-          <p:cNvPr id="1904860296" name="Slide Image Placeholder 1"/>
+          <p:cNvPr id="1897500666" name="Slide Image Placeholder 1"/>
           <p:cNvSpPr>
             <a:spLocks noChangeAspect="1" noGrp="1" noRot="1"/>
           </p:cNvSpPr>
@@ -961,7 +961,7 @@
       </p:sp>
       <p:sp>
         <p:nvSpPr>
-          <p:cNvPr id="256931860" name="Notes Placeholder 2"/>
+          <p:cNvPr id="1811296558" name="Notes Placeholder 2"/>
           <p:cNvSpPr>
             <a:spLocks noGrp="1"/>
           </p:cNvSpPr>
@@ -983,7 +983,7 @@
       </p:sp>
       <p:sp>
         <p:nvSpPr>
-          <p:cNvPr id="262495085" name="Slide Number Placeholder 3"/>
+          <p:cNvPr id="1449314117" name="Slide Number Placeholder 3"/>
           <p:cNvSpPr>
             <a:spLocks noGrp="1"/>
           </p:cNvSpPr>
@@ -1034,7 +1034,7 @@
       </p:grpSpPr>
       <p:sp>
         <p:nvSpPr>
-          <p:cNvPr id="1306180675" name="Slide Image Placeholder 1"/>
+          <p:cNvPr id="792608559" name="Slide Image Placeholder 1"/>
           <p:cNvSpPr>
             <a:spLocks noChangeAspect="1" noGrp="1" noRot="1"/>
           </p:cNvSpPr>
@@ -1046,7 +1046,7 @@
       </p:sp>
       <p:sp>
         <p:nvSpPr>
-          <p:cNvPr id="1843498073" name="Notes Placeholder 2"/>
+          <p:cNvPr id="167588895" name="Notes Placeholder 2"/>
           <p:cNvSpPr>
             <a:spLocks noGrp="1"/>
           </p:cNvSpPr>
@@ -1068,7 +1068,7 @@
       </p:sp>
       <p:sp>
         <p:nvSpPr>
-          <p:cNvPr id="1170130912" name="Slide Number Placeholder 3"/>
+          <p:cNvPr id="993591660" name="Slide Number Placeholder 3"/>
           <p:cNvSpPr>
             <a:spLocks noGrp="1"/>
           </p:cNvSpPr>
@@ -1119,7 +1119,7 @@
       </p:grpSpPr>
       <p:sp>
         <p:nvSpPr>
-          <p:cNvPr id="2037917213" name="Slide Image Placeholder 1"/>
+          <p:cNvPr id="1301283873" name="Slide Image Placeholder 1"/>
           <p:cNvSpPr>
             <a:spLocks noChangeAspect="1" noGrp="1" noRot="1"/>
           </p:cNvSpPr>
@@ -1131,7 +1131,7 @@
       </p:sp>
       <p:sp>
         <p:nvSpPr>
-          <p:cNvPr id="1956270095" name="Notes Placeholder 2"/>
+          <p:cNvPr id="229722821" name="Notes Placeholder 2"/>
           <p:cNvSpPr>
             <a:spLocks noGrp="1"/>
           </p:cNvSpPr>
@@ -1153,7 +1153,7 @@
       </p:sp>
       <p:sp>
         <p:nvSpPr>
-          <p:cNvPr id="1813001798" name="Slide Number Placeholder 3"/>
+          <p:cNvPr id="545772084" name="Slide Number Placeholder 3"/>
           <p:cNvSpPr>
             <a:spLocks noGrp="1"/>
           </p:cNvSpPr>
@@ -1204,7 +1204,7 @@
       </p:grpSpPr>
       <p:sp>
         <p:nvSpPr>
-          <p:cNvPr id="1257408769" name="Slide Image Placeholder 1"/>
+          <p:cNvPr id="166850935" name="Slide Image Placeholder 1"/>
           <p:cNvSpPr>
             <a:spLocks noChangeAspect="1" noGrp="1" noRot="1"/>
           </p:cNvSpPr>
@@ -1216,7 +1216,7 @@
       </p:sp>
       <p:sp>
         <p:nvSpPr>
-          <p:cNvPr id="1453484464" name="Notes Placeholder 2"/>
+          <p:cNvPr id="2122383909" name="Notes Placeholder 2"/>
           <p:cNvSpPr>
             <a:spLocks noGrp="1"/>
           </p:cNvSpPr>
@@ -1238,7 +1238,7 @@
       </p:sp>
       <p:sp>
         <p:nvSpPr>
-          <p:cNvPr id="1330786355" name="Slide Number Placeholder 3"/>
+          <p:cNvPr id="305991745" name="Slide Number Placeholder 3"/>
           <p:cNvSpPr>
             <a:spLocks noGrp="1"/>
           </p:cNvSpPr>
@@ -1289,7 +1289,7 @@
       </p:grpSpPr>
       <p:sp>
         <p:nvSpPr>
-          <p:cNvPr id="1523799460" name="Slide Image Placeholder 1"/>
+          <p:cNvPr id="1294111014" name="Slide Image Placeholder 1"/>
           <p:cNvSpPr>
             <a:spLocks noChangeAspect="1" noGrp="1" noRot="1"/>
           </p:cNvSpPr>
@@ -1301,7 +1301,7 @@
       </p:sp>
       <p:sp>
         <p:nvSpPr>
-          <p:cNvPr id="958540731" name="Notes Placeholder 2"/>
+          <p:cNvPr id="1729696408" name="Notes Placeholder 2"/>
           <p:cNvSpPr>
             <a:spLocks noGrp="1"/>
           </p:cNvSpPr>
@@ -1323,7 +1323,7 @@
       </p:sp>
       <p:sp>
         <p:nvSpPr>
-          <p:cNvPr id="71238620" name="Slide Number Placeholder 3"/>
+          <p:cNvPr id="1721391838" name="Slide Number Placeholder 3"/>
           <p:cNvSpPr>
             <a:spLocks noGrp="1"/>
           </p:cNvSpPr>
@@ -1544,7 +1544,7 @@
       </p:grpSpPr>
       <p:sp>
         <p:nvSpPr>
-          <p:cNvPr id="2061537826" name="Slide Image Placeholder 1"/>
+          <p:cNvPr id="2000243518" name="Slide Image Placeholder 1"/>
           <p:cNvSpPr>
             <a:spLocks noChangeAspect="1" noGrp="1" noRot="1"/>
           </p:cNvSpPr>
@@ -1556,7 +1556,7 @@
       </p:sp>
       <p:sp>
         <p:nvSpPr>
-          <p:cNvPr id="1698493071" name="Notes Placeholder 2"/>
+          <p:cNvPr id="680134826" name="Notes Placeholder 2"/>
           <p:cNvSpPr>
             <a:spLocks noGrp="1"/>
           </p:cNvSpPr>
@@ -1578,7 +1578,7 @@
       </p:sp>
       <p:sp>
         <p:nvSpPr>
-          <p:cNvPr id="1792982272" name="Slide Number Placeholder 3"/>
+          <p:cNvPr id="419717649" name="Slide Number Placeholder 3"/>
           <p:cNvSpPr>
             <a:spLocks noGrp="1"/>
           </p:cNvSpPr>
@@ -1714,7 +1714,7 @@
       </p:grpSpPr>
       <p:sp>
         <p:nvSpPr>
-          <p:cNvPr id="2028843225" name="Title 1"/>
+          <p:cNvPr id="1448717769" name="Title 1"/>
           <p:cNvSpPr>
             <a:spLocks noGrp="1"/>
           </p:cNvSpPr>
@@ -1749,7 +1749,7 @@
       </p:sp>
       <p:sp>
         <p:nvSpPr>
-          <p:cNvPr id="1211600737" name="Subtitle 2"/>
+          <p:cNvPr id="85008547" name="Subtitle 2"/>
           <p:cNvSpPr>
             <a:spLocks noGrp="1"/>
           </p:cNvSpPr>
@@ -1817,7 +1817,7 @@
       </p:sp>
       <p:sp>
         <p:nvSpPr>
-          <p:cNvPr id="898336554" name="Date Placeholder 3"/>
+          <p:cNvPr id="635512052" name="Date Placeholder 3"/>
           <p:cNvSpPr>
             <a:spLocks noGrp="1"/>
           </p:cNvSpPr>
@@ -1843,7 +1843,7 @@
       </p:sp>
       <p:sp>
         <p:nvSpPr>
-          <p:cNvPr id="1499356894" name="Footer Placeholder 4"/>
+          <p:cNvPr id="251749584" name="Footer Placeholder 4"/>
           <p:cNvSpPr>
             <a:spLocks noGrp="1"/>
           </p:cNvSpPr>
@@ -1865,7 +1865,7 @@
       </p:sp>
       <p:sp>
         <p:nvSpPr>
-          <p:cNvPr id="333492766" name="Slide Number Placeholder 5"/>
+          <p:cNvPr id="2005432501" name="Slide Number Placeholder 5"/>
           <p:cNvSpPr>
             <a:spLocks noGrp="1"/>
           </p:cNvSpPr>
@@ -1916,7 +1916,7 @@
       </p:grpSpPr>
       <p:sp>
         <p:nvSpPr>
-          <p:cNvPr id="971245133" name="Title 1"/>
+          <p:cNvPr id="1487501295" name="Title 1"/>
           <p:cNvSpPr>
             <a:spLocks noGrp="1"/>
           </p:cNvSpPr>
@@ -1942,7 +1942,7 @@
       </p:sp>
       <p:sp>
         <p:nvSpPr>
-          <p:cNvPr id="824475277" name="Vertical Text Placeholder 2"/>
+          <p:cNvPr id="981967108" name="Vertical Text Placeholder 2"/>
           <p:cNvSpPr>
             <a:spLocks noGrp="1"/>
           </p:cNvSpPr>
@@ -2008,7 +2008,7 @@
       </p:sp>
       <p:sp>
         <p:nvSpPr>
-          <p:cNvPr id="1108581748" name="Date Placeholder 3"/>
+          <p:cNvPr id="2046440852" name="Date Placeholder 3"/>
           <p:cNvSpPr>
             <a:spLocks noGrp="1"/>
           </p:cNvSpPr>
@@ -2034,7 +2034,7 @@
       </p:sp>
       <p:sp>
         <p:nvSpPr>
-          <p:cNvPr id="1387668411" name="Footer Placeholder 4"/>
+          <p:cNvPr id="1468484678" name="Footer Placeholder 4"/>
           <p:cNvSpPr>
             <a:spLocks noGrp="1"/>
           </p:cNvSpPr>
@@ -2056,7 +2056,7 @@
       </p:sp>
       <p:sp>
         <p:nvSpPr>
-          <p:cNvPr id="1849048940" name="Slide Number Placeholder 5"/>
+          <p:cNvPr id="1134318994" name="Slide Number Placeholder 5"/>
           <p:cNvSpPr>
             <a:spLocks noGrp="1"/>
           </p:cNvSpPr>
@@ -2107,7 +2107,7 @@
       </p:grpSpPr>
       <p:sp>
         <p:nvSpPr>
-          <p:cNvPr id="1978342587" name="Vertical Title 1"/>
+          <p:cNvPr id="1788007632" name="Vertical Title 1"/>
           <p:cNvSpPr>
             <a:spLocks noGrp="1"/>
           </p:cNvSpPr>
@@ -2138,7 +2138,7 @@
       </p:sp>
       <p:sp>
         <p:nvSpPr>
-          <p:cNvPr id="451121903" name="Vertical Text Placeholder 2"/>
+          <p:cNvPr id="1748035462" name="Vertical Text Placeholder 2"/>
           <p:cNvSpPr>
             <a:spLocks noGrp="1"/>
           </p:cNvSpPr>
@@ -2209,7 +2209,7 @@
       </p:sp>
       <p:sp>
         <p:nvSpPr>
-          <p:cNvPr id="349333578" name="Date Placeholder 3"/>
+          <p:cNvPr id="1203994418" name="Date Placeholder 3"/>
           <p:cNvSpPr>
             <a:spLocks noGrp="1"/>
           </p:cNvSpPr>
@@ -2235,7 +2235,7 @@
       </p:sp>
       <p:sp>
         <p:nvSpPr>
-          <p:cNvPr id="1098645134" name="Footer Placeholder 4"/>
+          <p:cNvPr id="1076989770" name="Footer Placeholder 4"/>
           <p:cNvSpPr>
             <a:spLocks noGrp="1"/>
           </p:cNvSpPr>
@@ -2257,7 +2257,7 @@
       </p:sp>
       <p:sp>
         <p:nvSpPr>
-          <p:cNvPr id="656122952" name="Slide Number Placeholder 5"/>
+          <p:cNvPr id="453280495" name="Slide Number Placeholder 5"/>
           <p:cNvSpPr>
             <a:spLocks noGrp="1"/>
           </p:cNvSpPr>
@@ -2308,7 +2308,7 @@
       </p:grpSpPr>
       <p:sp>
         <p:nvSpPr>
-          <p:cNvPr id="2059368164" name="Title 1"/>
+          <p:cNvPr id="72671049" name="Title 1"/>
           <p:cNvSpPr>
             <a:spLocks noGrp="1"/>
           </p:cNvSpPr>
@@ -2334,7 +2334,7 @@
       </p:sp>
       <p:sp>
         <p:nvSpPr>
-          <p:cNvPr id="1485020390" name="Content Placeholder 2"/>
+          <p:cNvPr id="1610113547" name="Content Placeholder 2"/>
           <p:cNvSpPr>
             <a:spLocks noGrp="1"/>
           </p:cNvSpPr>
@@ -2400,7 +2400,7 @@
       </p:sp>
       <p:sp>
         <p:nvSpPr>
-          <p:cNvPr id="1766171673" name="Date Placeholder 3"/>
+          <p:cNvPr id="2010036016" name="Date Placeholder 3"/>
           <p:cNvSpPr>
             <a:spLocks noGrp="1"/>
           </p:cNvSpPr>
@@ -2426,7 +2426,7 @@
       </p:sp>
       <p:sp>
         <p:nvSpPr>
-          <p:cNvPr id="2008475335" name="Footer Placeholder 4"/>
+          <p:cNvPr id="460293043" name="Footer Placeholder 4"/>
           <p:cNvSpPr>
             <a:spLocks noGrp="1"/>
           </p:cNvSpPr>
@@ -2448,7 +2448,7 @@
       </p:sp>
       <p:sp>
         <p:nvSpPr>
-          <p:cNvPr id="894036957" name="Slide Number Placeholder 5"/>
+          <p:cNvPr id="1290225201" name="Slide Number Placeholder 5"/>
           <p:cNvSpPr>
             <a:spLocks noGrp="1"/>
           </p:cNvSpPr>
@@ -2499,7 +2499,7 @@
       </p:grpSpPr>
       <p:sp>
         <p:nvSpPr>
-          <p:cNvPr id="4818160" name="Title 1"/>
+          <p:cNvPr id="1571885712" name="Title 1"/>
           <p:cNvSpPr>
             <a:spLocks noGrp="1"/>
           </p:cNvSpPr>
@@ -2534,7 +2534,7 @@
       </p:sp>
       <p:sp>
         <p:nvSpPr>
-          <p:cNvPr id="1079399427" name="Text Placeholder 2"/>
+          <p:cNvPr id="1578894823" name="Text Placeholder 2"/>
           <p:cNvSpPr>
             <a:spLocks noGrp="1"/>
           </p:cNvSpPr>
@@ -2656,7 +2656,7 @@
       </p:sp>
       <p:sp>
         <p:nvSpPr>
-          <p:cNvPr id="698100207" name="Date Placeholder 3"/>
+          <p:cNvPr id="1041408207" name="Date Placeholder 3"/>
           <p:cNvSpPr>
             <a:spLocks noGrp="1"/>
           </p:cNvSpPr>
@@ -2682,7 +2682,7 @@
       </p:sp>
       <p:sp>
         <p:nvSpPr>
-          <p:cNvPr id="1832123180" name="Footer Placeholder 4"/>
+          <p:cNvPr id="128888014" name="Footer Placeholder 4"/>
           <p:cNvSpPr>
             <a:spLocks noGrp="1"/>
           </p:cNvSpPr>
@@ -2704,7 +2704,7 @@
       </p:sp>
       <p:sp>
         <p:nvSpPr>
-          <p:cNvPr id="1062434085" name="Slide Number Placeholder 5"/>
+          <p:cNvPr id="737600839" name="Slide Number Placeholder 5"/>
           <p:cNvSpPr>
             <a:spLocks noGrp="1"/>
           </p:cNvSpPr>
@@ -2755,7 +2755,7 @@
       </p:grpSpPr>
       <p:sp>
         <p:nvSpPr>
-          <p:cNvPr id="1858567658" name="Title 1"/>
+          <p:cNvPr id="1615590515" name="Title 1"/>
           <p:cNvSpPr>
             <a:spLocks noGrp="1"/>
           </p:cNvSpPr>
@@ -2781,7 +2781,7 @@
       </p:sp>
       <p:sp>
         <p:nvSpPr>
-          <p:cNvPr id="272591727" name="Content Placeholder 2"/>
+          <p:cNvPr id="1297519050" name="Content Placeholder 2"/>
           <p:cNvSpPr>
             <a:spLocks noGrp="1"/>
           </p:cNvSpPr>
@@ -2852,7 +2852,7 @@
       </p:sp>
       <p:sp>
         <p:nvSpPr>
-          <p:cNvPr id="777142350" name="Content Placeholder 3"/>
+          <p:cNvPr id="2033232442" name="Content Placeholder 3"/>
           <p:cNvSpPr>
             <a:spLocks noGrp="1"/>
           </p:cNvSpPr>
@@ -2923,7 +2923,7 @@
       </p:sp>
       <p:sp>
         <p:nvSpPr>
-          <p:cNvPr id="1590750364" name="Date Placeholder 4"/>
+          <p:cNvPr id="105172854" name="Date Placeholder 4"/>
           <p:cNvSpPr>
             <a:spLocks noGrp="1"/>
           </p:cNvSpPr>
@@ -2949,7 +2949,7 @@
       </p:sp>
       <p:sp>
         <p:nvSpPr>
-          <p:cNvPr id="420857151" name="Footer Placeholder 5"/>
+          <p:cNvPr id="957060449" name="Footer Placeholder 5"/>
           <p:cNvSpPr>
             <a:spLocks noGrp="1"/>
           </p:cNvSpPr>
@@ -2971,7 +2971,7 @@
       </p:sp>
       <p:sp>
         <p:nvSpPr>
-          <p:cNvPr id="1820612314" name="Slide Number Placeholder 6"/>
+          <p:cNvPr id="664066949" name="Slide Number Placeholder 6"/>
           <p:cNvSpPr>
             <a:spLocks noGrp="1"/>
           </p:cNvSpPr>
@@ -3022,7 +3022,7 @@
       </p:grpSpPr>
       <p:sp>
         <p:nvSpPr>
-          <p:cNvPr id="1862803555" name="Title 1"/>
+          <p:cNvPr id="2069276429" name="Title 1"/>
           <p:cNvSpPr>
             <a:spLocks noGrp="1"/>
           </p:cNvSpPr>
@@ -3053,7 +3053,7 @@
       </p:sp>
       <p:sp>
         <p:nvSpPr>
-          <p:cNvPr id="894038830" name="Text Placeholder 2"/>
+          <p:cNvPr id="1363417848" name="Text Placeholder 2"/>
           <p:cNvSpPr>
             <a:spLocks noGrp="1"/>
           </p:cNvSpPr>
@@ -3121,7 +3121,7 @@
       </p:sp>
       <p:sp>
         <p:nvSpPr>
-          <p:cNvPr id="1666568284" name="Content Placeholder 3"/>
+          <p:cNvPr id="1968855544" name="Content Placeholder 3"/>
           <p:cNvSpPr>
             <a:spLocks noGrp="1"/>
           </p:cNvSpPr>
@@ -3192,7 +3192,7 @@
       </p:sp>
       <p:sp>
         <p:nvSpPr>
-          <p:cNvPr id="218840421" name="Text Placeholder 4"/>
+          <p:cNvPr id="4793527" name="Text Placeholder 4"/>
           <p:cNvSpPr>
             <a:spLocks noGrp="1"/>
           </p:cNvSpPr>
@@ -3260,7 +3260,7 @@
       </p:sp>
       <p:sp>
         <p:nvSpPr>
-          <p:cNvPr id="1094059749" name="Content Placeholder 5"/>
+          <p:cNvPr id="1438947646" name="Content Placeholder 5"/>
           <p:cNvSpPr>
             <a:spLocks noGrp="1"/>
           </p:cNvSpPr>
@@ -3331,7 +3331,7 @@
       </p:sp>
       <p:sp>
         <p:nvSpPr>
-          <p:cNvPr id="678859312" name="Date Placeholder 6"/>
+          <p:cNvPr id="783465911" name="Date Placeholder 6"/>
           <p:cNvSpPr>
             <a:spLocks noGrp="1"/>
           </p:cNvSpPr>
@@ -3357,7 +3357,7 @@
       </p:sp>
       <p:sp>
         <p:nvSpPr>
-          <p:cNvPr id="192487608" name="Footer Placeholder 7"/>
+          <p:cNvPr id="2137210001" name="Footer Placeholder 7"/>
           <p:cNvSpPr>
             <a:spLocks noGrp="1"/>
           </p:cNvSpPr>
@@ -3379,7 +3379,7 @@
       </p:sp>
       <p:sp>
         <p:nvSpPr>
-          <p:cNvPr id="862285833" name="Slide Number Placeholder 8"/>
+          <p:cNvPr id="1736869842" name="Slide Number Placeholder 8"/>
           <p:cNvSpPr>
             <a:spLocks noGrp="1"/>
           </p:cNvSpPr>
@@ -3430,7 +3430,7 @@
       </p:grpSpPr>
       <p:sp>
         <p:nvSpPr>
-          <p:cNvPr id="885235263" name="Title 1"/>
+          <p:cNvPr id="2306764" name="Title 1"/>
           <p:cNvSpPr>
             <a:spLocks noGrp="1"/>
           </p:cNvSpPr>
@@ -3456,7 +3456,7 @@
       </p:sp>
       <p:sp>
         <p:nvSpPr>
-          <p:cNvPr id="1975903737" name="Date Placeholder 2"/>
+          <p:cNvPr id="1422670340" name="Date Placeholder 2"/>
           <p:cNvSpPr>
             <a:spLocks noGrp="1"/>
           </p:cNvSpPr>
@@ -3482,7 +3482,7 @@
       </p:sp>
       <p:sp>
         <p:nvSpPr>
-          <p:cNvPr id="940320898" name="Footer Placeholder 3"/>
+          <p:cNvPr id="756977321" name="Footer Placeholder 3"/>
           <p:cNvSpPr>
             <a:spLocks noGrp="1"/>
           </p:cNvSpPr>
@@ -3504,7 +3504,7 @@
       </p:sp>
       <p:sp>
         <p:nvSpPr>
-          <p:cNvPr id="1277158616" name="Slide Number Placeholder 4"/>
+          <p:cNvPr id="1787681802" name="Slide Number Placeholder 4"/>
           <p:cNvSpPr>
             <a:spLocks noGrp="1"/>
           </p:cNvSpPr>
@@ -3555,7 +3555,7 @@
       </p:grpSpPr>
       <p:sp>
         <p:nvSpPr>
-          <p:cNvPr id="2108010052" name="Date Placeholder 1"/>
+          <p:cNvPr id="1674988954" name="Date Placeholder 1"/>
           <p:cNvSpPr>
             <a:spLocks noGrp="1"/>
           </p:cNvSpPr>
@@ -3581,7 +3581,7 @@
       </p:sp>
       <p:sp>
         <p:nvSpPr>
-          <p:cNvPr id="1263672603" name="Footer Placeholder 2"/>
+          <p:cNvPr id="1952908994" name="Footer Placeholder 2"/>
           <p:cNvSpPr>
             <a:spLocks noGrp="1"/>
           </p:cNvSpPr>
@@ -3603,7 +3603,7 @@
       </p:sp>
       <p:sp>
         <p:nvSpPr>
-          <p:cNvPr id="528570777" name="Slide Number Placeholder 3"/>
+          <p:cNvPr id="1036921911" name="Slide Number Placeholder 3"/>
           <p:cNvSpPr>
             <a:spLocks noGrp="1"/>
           </p:cNvSpPr>
@@ -3654,7 +3654,7 @@
       </p:grpSpPr>
       <p:sp>
         <p:nvSpPr>
-          <p:cNvPr id="180930692" name="Title 1"/>
+          <p:cNvPr id="1720024534" name="Title 1"/>
           <p:cNvSpPr>
             <a:spLocks noGrp="1"/>
           </p:cNvSpPr>
@@ -3689,7 +3689,7 @@
       </p:sp>
       <p:sp>
         <p:nvSpPr>
-          <p:cNvPr id="332707166" name="Content Placeholder 2"/>
+          <p:cNvPr id="14319709" name="Content Placeholder 2"/>
           <p:cNvSpPr>
             <a:spLocks noGrp="1"/>
           </p:cNvSpPr>
@@ -3788,7 +3788,7 @@
       </p:sp>
       <p:sp>
         <p:nvSpPr>
-          <p:cNvPr id="215945361" name="Text Placeholder 3"/>
+          <p:cNvPr id="230325581" name="Text Placeholder 3"/>
           <p:cNvSpPr>
             <a:spLocks noGrp="1"/>
           </p:cNvSpPr>
@@ -3856,7 +3856,7 @@
       </p:sp>
       <p:sp>
         <p:nvSpPr>
-          <p:cNvPr id="282240511" name="Date Placeholder 4"/>
+          <p:cNvPr id="1867042307" name="Date Placeholder 4"/>
           <p:cNvSpPr>
             <a:spLocks noGrp="1"/>
           </p:cNvSpPr>
@@ -3882,7 +3882,7 @@
       </p:sp>
       <p:sp>
         <p:nvSpPr>
-          <p:cNvPr id="282185286" name="Footer Placeholder 5"/>
+          <p:cNvPr id="618672261" name="Footer Placeholder 5"/>
           <p:cNvSpPr>
             <a:spLocks noGrp="1"/>
           </p:cNvSpPr>
@@ -3904,7 +3904,7 @@
       </p:sp>
       <p:sp>
         <p:nvSpPr>
-          <p:cNvPr id="1619173677" name="Slide Number Placeholder 6"/>
+          <p:cNvPr id="241213954" name="Slide Number Placeholder 6"/>
           <p:cNvSpPr>
             <a:spLocks noGrp="1"/>
           </p:cNvSpPr>
@@ -3955,7 +3955,7 @@
       </p:grpSpPr>
       <p:sp>
         <p:nvSpPr>
-          <p:cNvPr id="705604681" name="Title 1"/>
+          <p:cNvPr id="153701313" name="Title 1"/>
           <p:cNvSpPr>
             <a:spLocks noGrp="1"/>
           </p:cNvSpPr>
@@ -3990,7 +3990,7 @@
       </p:sp>
       <p:sp>
         <p:nvSpPr>
-          <p:cNvPr id="829405797" name="Picture Placeholder 2"/>
+          <p:cNvPr id="1691216338" name="Picture Placeholder 2"/>
           <p:cNvSpPr>
             <a:spLocks noChangeAspect="1" noGrp="1"/>
           </p:cNvSpPr>
@@ -4058,7 +4058,7 @@
       </p:sp>
       <p:sp>
         <p:nvSpPr>
-          <p:cNvPr id="2096363917" name="Text Placeholder 3"/>
+          <p:cNvPr id="1125557012" name="Text Placeholder 3"/>
           <p:cNvSpPr>
             <a:spLocks noGrp="1"/>
           </p:cNvSpPr>
@@ -4126,7 +4126,7 @@
       </p:sp>
       <p:sp>
         <p:nvSpPr>
-          <p:cNvPr id="1940222554" name="Date Placeholder 4"/>
+          <p:cNvPr id="629394206" name="Date Placeholder 4"/>
           <p:cNvSpPr>
             <a:spLocks noGrp="1"/>
           </p:cNvSpPr>
@@ -4152,7 +4152,7 @@
       </p:sp>
       <p:sp>
         <p:nvSpPr>
-          <p:cNvPr id="992344267" name="Footer Placeholder 5"/>
+          <p:cNvPr id="576655728" name="Footer Placeholder 5"/>
           <p:cNvSpPr>
             <a:spLocks noGrp="1"/>
           </p:cNvSpPr>
@@ -4174,7 +4174,7 @@
       </p:sp>
       <p:sp>
         <p:nvSpPr>
-          <p:cNvPr id="1079004194" name="Slide Number Placeholder 6"/>
+          <p:cNvPr id="1582324246" name="Slide Number Placeholder 6"/>
           <p:cNvSpPr>
             <a:spLocks noGrp="1"/>
           </p:cNvSpPr>
@@ -4233,7 +4233,7 @@
       </p:grpSpPr>
       <p:sp>
         <p:nvSpPr>
-          <p:cNvPr id="494850575" name="Title Placeholder 1"/>
+          <p:cNvPr id="1880531464" name="Title Placeholder 1"/>
           <p:cNvSpPr>
             <a:spLocks noGrp="1"/>
           </p:cNvSpPr>
@@ -4269,7 +4269,7 @@
       </p:sp>
       <p:sp>
         <p:nvSpPr>
-          <p:cNvPr id="158836969" name="Text Placeholder 2"/>
+          <p:cNvPr id="524328490" name="Text Placeholder 2"/>
           <p:cNvSpPr>
             <a:spLocks noGrp="1"/>
           </p:cNvSpPr>
@@ -4345,7 +4345,7 @@
       </p:sp>
       <p:sp>
         <p:nvSpPr>
-          <p:cNvPr id="1526702293" name="Date Placeholder 3"/>
+          <p:cNvPr id="1689026469" name="Date Placeholder 3"/>
           <p:cNvSpPr>
             <a:spLocks noGrp="1"/>
           </p:cNvSpPr>
@@ -4389,7 +4389,7 @@
       </p:sp>
       <p:sp>
         <p:nvSpPr>
-          <p:cNvPr id="1727740862" name="Footer Placeholder 4"/>
+          <p:cNvPr id="768962525" name="Footer Placeholder 4"/>
           <p:cNvSpPr>
             <a:spLocks noGrp="1"/>
           </p:cNvSpPr>
@@ -4429,7 +4429,7 @@
       </p:sp>
       <p:sp>
         <p:nvSpPr>
-          <p:cNvPr id="2001855367" name="Slide Number Placeholder 5"/>
+          <p:cNvPr id="396728629" name="Slide Number Placeholder 5"/>
           <p:cNvSpPr>
             <a:spLocks noGrp="1"/>
           </p:cNvSpPr>
@@ -4789,7 +4789,7 @@
       </p:grpSpPr>
       <p:sp>
         <p:nvSpPr>
-          <p:cNvPr id="1469333195" name="Title 1"/>
+          <p:cNvPr id="1570881495" name="Title 1"/>
           <p:cNvSpPr>
             <a:spLocks noGrp="1"/>
           </p:cNvSpPr>
@@ -4833,7 +4833,7 @@
       </p:sp>
       <p:sp>
         <p:nvSpPr>
-          <p:cNvPr id="278420358" name="Subtitle 2"/>
+          <p:cNvPr id="1479465249" name="Subtitle 2"/>
           <p:cNvSpPr>
             <a:spLocks noGrp="1"/>
           </p:cNvSpPr>
@@ -4925,7 +4925,7 @@
       </p:grpSpPr>
       <p:sp>
         <p:nvSpPr>
-          <p:cNvPr id="323288811" name="Title 1"/>
+          <p:cNvPr id="414271399" name="Title 1"/>
           <p:cNvSpPr>
             <a:spLocks noGrp="1"/>
           </p:cNvSpPr>
@@ -4964,7 +4964,7 @@
       </p:sp>
       <p:sp>
         <p:nvSpPr>
-          <p:cNvPr id="1981684711" name="Content Placeholder 2"/>
+          <p:cNvPr id="978778887" name="Content Placeholder 2"/>
           <p:cNvSpPr>
             <a:spLocks noGrp="1"/>
           </p:cNvSpPr>
@@ -5120,7 +5120,7 @@
       </p:sp>
       <p:sp>
         <p:nvSpPr>
-          <p:cNvPr id="1571454032" name="Content Placeholder 2"/>
+          <p:cNvPr id="39772373" name="Content Placeholder 2"/>
           <p:cNvSpPr>
             <a:spLocks noGrp="1"/>
           </p:cNvSpPr>
@@ -5377,7 +5377,7 @@
       </p:sp>
       <p:sp>
         <p:nvSpPr>
-          <p:cNvPr id="706751710" name="Content Placeholder 2"/>
+          <p:cNvPr id="1959674507" name="Content Placeholder 2"/>
           <p:cNvSpPr>
             <a:spLocks noGrp="1"/>
           </p:cNvSpPr>
@@ -5595,7 +5595,31 @@
                 <a:latin typeface="Ubuntu Sans"/>
                 <a:cs typeface="Ubuntu Sans"/>
               </a:rPr>
-              <a:t>Довършване на проекта</a:t>
+              <a:t>Направихме проекта да функционира </a:t>
+            </a:r>
+            <a:endParaRPr lang="bg-BG">
+              <a:solidFill>
+                <a:schemeClr val="bg1"/>
+              </a:solidFill>
+              <a:latin typeface="Ubuntu Sans"/>
+              <a:cs typeface="Ubuntu Sans"/>
+            </a:endParaRPr>
+          </a:p>
+          <a:p>
+            <a:pPr marL="0" indent="0" algn="ctr">
+              <a:buFont typeface="Arial"/>
+              <a:buNone/>
+              <a:defRPr/>
+            </a:pPr>
+            <a:r>
+              <a:rPr lang="en-US">
+                <a:solidFill>
+                  <a:schemeClr val="bg1"/>
+                </a:solidFill>
+                <a:latin typeface="Ubuntu Sans"/>
+                <a:cs typeface="Ubuntu Sans"/>
+              </a:rPr>
+              <a:t>Live demo</a:t>
             </a:r>
             <a:endParaRPr lang="bg-BG">
               <a:solidFill>
@@ -5666,7 +5690,7 @@
       </p:grpSpPr>
       <p:sp>
         <p:nvSpPr>
-          <p:cNvPr id="1627065319" name="Title 1"/>
+          <p:cNvPr id="1658362274" name="Title 1"/>
           <p:cNvSpPr>
             <a:spLocks noGrp="1"/>
           </p:cNvSpPr>
@@ -5716,7 +5740,7 @@
       </p:sp>
       <p:sp>
         <p:nvSpPr>
-          <p:cNvPr id="2069464295" name=""/>
+          <p:cNvPr id="2020181968" name=""/>
           <p:cNvSpPr txBox="1"/>
           <p:nvPr/>
         </p:nvSpPr>
@@ -5744,7 +5768,7 @@
       </p:sp>
       <p:sp>
         <p:nvSpPr>
-          <p:cNvPr id="709497198" name=""/>
+          <p:cNvPr id="1174344096" name=""/>
           <p:cNvSpPr txBox="1"/>
           <p:nvPr/>
         </p:nvSpPr>
@@ -5901,7 +5925,7 @@
       </p:grpSpPr>
       <p:sp>
         <p:nvSpPr>
-          <p:cNvPr id="1704329715" name="Title 1"/>
+          <p:cNvPr id="51537487" name="Title 1"/>
           <p:cNvSpPr>
             <a:spLocks noGrp="1"/>
           </p:cNvSpPr>
@@ -5934,7 +5958,7 @@
       </p:sp>
       <p:sp>
         <p:nvSpPr>
-          <p:cNvPr id="417137689" name=""/>
+          <p:cNvPr id="2098803672" name=""/>
           <p:cNvSpPr txBox="1"/>
           <p:nvPr/>
         </p:nvSpPr>
@@ -6200,7 +6224,7 @@
       </p:grpSpPr>
       <p:sp>
         <p:nvSpPr>
-          <p:cNvPr id="338200200" name="Title 1"/>
+          <p:cNvPr id="15057356" name="Title 1"/>
           <p:cNvSpPr>
             <a:spLocks noGrp="1"/>
           </p:cNvSpPr>
@@ -6237,7 +6261,7 @@
       </p:sp>
       <p:sp>
         <p:nvSpPr>
-          <p:cNvPr id="552880449" name=""/>
+          <p:cNvPr id="888635277" name=""/>
           <p:cNvSpPr txBox="1"/>
           <p:nvPr/>
         </p:nvSpPr>
@@ -6417,7 +6441,7 @@
       </p:grpSpPr>
       <p:sp>
         <p:nvSpPr>
-          <p:cNvPr id="2102016768" name=""/>
+          <p:cNvPr id="1622186683" name=""/>
           <p:cNvSpPr txBox="1"/>
           <p:nvPr/>
         </p:nvSpPr>
@@ -6457,7 +6481,7 @@
       </p:sp>
       <p:pic>
         <p:nvPicPr>
-          <p:cNvPr id="1912857810" name=""/>
+          <p:cNvPr id="601598284" name=""/>
           <p:cNvPicPr>
             <a:picLocks noChangeAspect="1"/>
           </p:cNvPicPr>
@@ -6512,7 +6536,7 @@
       </p:grpSpPr>
       <p:sp>
         <p:nvSpPr>
-          <p:cNvPr id="1848301581" name="Title 1"/>
+          <p:cNvPr id="469450910" name="Title 1"/>
           <p:cNvSpPr>
             <a:spLocks noGrp="1"/>
           </p:cNvSpPr>
@@ -7093,7 +7117,7 @@
       </p:grpSpPr>
       <p:sp>
         <p:nvSpPr>
-          <p:cNvPr id="200007601" name="Title 1"/>
+          <p:cNvPr id="2101919334" name="Title 1"/>
           <p:cNvSpPr>
             <a:spLocks noGrp="1"/>
           </p:cNvSpPr>
@@ -7136,7 +7160,7 @@
       </p:sp>
       <p:sp>
         <p:nvSpPr>
-          <p:cNvPr id="1265942445" name=""/>
+          <p:cNvPr id="916827429" name=""/>
           <p:cNvSpPr txBox="1"/>
           <p:nvPr/>
         </p:nvSpPr>
@@ -7326,7 +7350,7 @@
       </p:grpSpPr>
       <p:sp>
         <p:nvSpPr>
-          <p:cNvPr id="1835088990" name="Title 1"/>
+          <p:cNvPr id="1296131451" name="Title 1"/>
           <p:cNvSpPr>
             <a:spLocks noGrp="1"/>
           </p:cNvSpPr>
@@ -7365,7 +7389,7 @@
       </p:sp>
       <p:sp>
         <p:nvSpPr>
-          <p:cNvPr id="1891568958" name="Content Placeholder 2"/>
+          <p:cNvPr id="2049505453" name="Content Placeholder 2"/>
           <p:cNvSpPr>
             <a:spLocks noGrp="1"/>
           </p:cNvSpPr>
@@ -7521,7 +7545,7 @@
       </p:grpSpPr>
       <p:sp>
         <p:nvSpPr>
-          <p:cNvPr id="987115882" name="Title 1"/>
+          <p:cNvPr id="1891512369" name="Title 1"/>
           <p:cNvSpPr>
             <a:spLocks noGrp="1"/>
           </p:cNvSpPr>
@@ -7887,7 +7911,7 @@
       </p:grpSpPr>
       <p:sp>
         <p:nvSpPr>
-          <p:cNvPr id="2118172442" name=""/>
+          <p:cNvPr id="569801252" name=""/>
           <p:cNvSpPr txBox="1"/>
           <p:nvPr/>
         </p:nvSpPr>

</xml_diff>